<commit_message>
Docs: reflect NT extension and WA removal across all documentation
* README: network now covers eastern Australia + the Northern Territory
  (Amadeus/Beetaloo -> Darwin, NGP interconnector); WA explicitly excluded.
* TECHNICAL_DOCS: new "Northern Territory Extension" section (nodes, pipelines,
  demand, and NGP map geometry validated against the AEMO gas map v2021); notes
  WA was evaluated and not included.
* TODO: mark NT extension done; log the WA prototype as built-then-reverted.
* Gas_Market_Model_Documentation.docx: intro now says east coast + NT (WA excluded).
* Building_GARY_with_AI.pptx: 14 -> 18 nodes, span "NT and Queensland to Tasmania",
  "Eastern Australian & NT gas market".

Co-Authored-By: Claude Opus 4.8 <noreply@anthropic.com>
</commit_message>
<xml_diff>
--- a/Building_GARY_with_AI.pptx
+++ b/Building_GARY_with_AI.pptx
@@ -3317,7 +3317,7 @@
                 </a:solidFill>
                 <a:latin typeface="Calibri"/>
               </a:rPr>
-              <a:t>A least-cost model of the Eastern Australian gas market — built with an AI coding assistant</a:t>
+              <a:t>A least-cost model of the Eastern Australian &amp; NT gas market — built with an AI coding assistant</a:t>
             </a:r>
           </a:p>
         </p:txBody>
@@ -3359,7 +3359,7 @@
                 </a:solidFill>
                 <a:latin typeface="Calibri"/>
               </a:rPr>
-              <a:t>Eastern Australian gas market   ·   2025–2050   ·   nodal linear program</a:t>
+              <a:t>Eastern Australian &amp; NT gas market   ·   2025–2050   ·   nodal linear program</a:t>
             </a:r>
           </a:p>
         </p:txBody>
@@ -5852,7 +5852,7 @@
                 </a:solidFill>
                 <a:latin typeface="Calibri"/>
               </a:rPr>
-              <a:t>A nodal, least-cost optimisation of the Eastern Australian gas market that decides — for every day of every year to 2050 — where gas is produced, how it flows through the pipeline network, and what it costs at each hub.</a:t>
+              <a:t>A nodal, least-cost optimisation of the Eastern Australian &amp; NT gas market that decides — for every day of every year to 2050 — where gas is produced, how it flows through the pipeline network, and what it costs at each hub.</a:t>
             </a:r>
           </a:p>
         </p:txBody>
@@ -5982,7 +5982,7 @@
                 </a:solidFill>
                 <a:latin typeface="Calibri"/>
               </a:rPr>
-              <a:t>14 nodes</a:t>
+              <a:t>18 nodes</a:t>
             </a:r>
           </a:p>
         </p:txBody>
@@ -6024,7 +6024,7 @@
                 </a:solidFill>
                 <a:latin typeface="Calibri"/>
               </a:rPr>
-              <a:t>Producers, demand hubs, LNG trains and storages from Queensland to Tasmania</a:t>
+              <a:t>Producers, demand hubs, LNG trains and storages from the Northern Territory and Queensland to Tasmania</a:t>
             </a:r>
           </a:p>
         </p:txBody>

</xml_diff>